<commit_message>
Update speaker notes and arrow formatting in BCC351 presentation
</commit_message>
<xml_diff>
--- a/Club_Connect_Mini_Project_BCC351.pptx
+++ b/Club_Connect_Mini_Project_BCC351.pptx
@@ -6,7 +6,7 @@
   </p:sldMasterIdLst>
   <p:sldIdLst>
     <p:sldId id="256" r:id="rId7"/>
-    <p:sldId id="257" r:id="rId8"/>
+    <p:sldId id="257" r:id="rId9"/>
     <p:sldId id="258" r:id="rId10"/>
     <p:sldId id="259" r:id="rId11"/>
     <p:sldId id="260" r:id="rId12"/>
@@ -516,7 +516,7 @@
           <a:lstStyle/>
           <a:p>
             <a:r>
-              <a:t>Introduce Club Connect as an engineering response to scattered WhatsApp groups and manual Google forms, connecting directly to AKTU's BCC351 learning outcomes.</a:t>
+              <a:t>Good morning respected faculty. Today our team is presenting our BCC351 Mini Project titled 'Club Connect'. It is an all-in-one digital hub for all student clubs and events in our college, featuring an instant physical ID card barcode scanner for login.</a:t>
             </a:r>
           </a:p>
         </p:txBody>
@@ -586,7 +586,7 @@
           <a:lstStyle/>
           <a:p>
             <a:r>
-              <a:t>Highlight the 4 pillars of the app: Smart Barcode Login, Club Directory, Event Ticketing, and the President Management Dashboard.</a:t>
+              <a:t>Explain why we adopted Agile Scrum instead of Waterfall. Sprints allowed us to test barcode scanning and portal sync continuously, ensuring our demo worked flawlessly.</a:t>
             </a:r>
           </a:p>
         </p:txBody>
@@ -656,7 +656,7 @@
           <a:lstStyle/>
           <a:p>
             <a:r>
-              <a:t>Show that Club Connect avoids every single common project trap: it is not a generic clone, it has continuous Git commits, and it is live 24/7 on the cloud.</a:t>
+              <a:t>Highlight the 4 pillars of the app: Smart Barcode Login, Club Directory, Event Ticketing, and the President Management Dashboard.</a:t>
             </a:r>
           </a:p>
         </p:txBody>
@@ -726,7 +726,7 @@
           <a:lstStyle/>
           <a:p>
             <a:r>
-              <a:t>Present the verification results: we tested real student ID cards like Yash Kumar, achieving instant portal synchronization and 100% healthy HTTP 200 responses on Render cloud.</a:t>
+              <a:t>Show that Club Connect avoids every single common project trap: it is not a generic clone, it has continuous Git commits, and it is live 24/7 on the cloud.</a:t>
             </a:r>
           </a:p>
         </p:txBody>
@@ -796,7 +796,7 @@
           <a:lstStyle/>
           <a:p>
             <a:r>
-              <a:t>Discuss future enhancements: QR attendance scanning at workshop doors, automatic PDF participation certificates, and push notifications for event updates.</a:t>
+              <a:t>Present the verification results: we tested real student ID cards like Yash Kumar, achieving instant portal synchronization and 100% healthy HTTP 200 responses on Render cloud.</a:t>
             </a:r>
           </a:p>
         </p:txBody>
@@ -866,6 +866,76 @@
           <a:lstStyle/>
           <a:p>
             <a:r>
+              <a:t>Discuss future enhancements: QR attendance scanning at workshop doors, automatic PDF participation certificates, and push notifications for event updates.</a:t>
+            </a:r>
+          </a:p>
+        </p:txBody>
+      </p:sp>
+      <p:sp>
+        <p:nvSpPr>
+          <p:cNvPr id="4" name="Slide Number Placeholder 3"/>
+          <p:cNvSpPr>
+            <a:spLocks noGrp="1"/>
+          </p:cNvSpPr>
+          <p:nvPr>
+            <p:ph type="sldNum" idx="5" sz="quarter"/>
+          </p:nvPr>
+        </p:nvSpPr>
+        <p:spPr/>
+      </p:sp>
+    </p:spTree>
+  </p:cSld>
+  <p:clrMapOvr>
+    <a:masterClrMapping/>
+  </p:clrMapOvr>
+</p:notes>
+</file>
+
+<file path=ppt/notesSlides/notesSlide15.xml><?xml version="1.0" encoding="utf-8"?>
+<p:notes xmlns:a="http://schemas.openxmlformats.org/drawingml/2006/main" xmlns:p="http://schemas.openxmlformats.org/presentationml/2006/main" xmlns:r="http://schemas.openxmlformats.org/officeDocument/2006/relationships">
+  <p:cSld>
+    <p:spTree>
+      <p:nvGrpSpPr>
+        <p:cNvPr id="1" name=""/>
+        <p:cNvGrpSpPr/>
+        <p:nvPr/>
+      </p:nvGrpSpPr>
+      <p:grpSpPr>
+        <a:xfrm>
+          <a:off x="0" y="0"/>
+          <a:ext cx="0" cy="0"/>
+          <a:chOff x="0" y="0"/>
+          <a:chExt cx="0" cy="0"/>
+        </a:xfrm>
+      </p:grpSpPr>
+      <p:sp>
+        <p:nvSpPr>
+          <p:cNvPr id="2" name="Slide Image Placeholder 1"/>
+          <p:cNvSpPr>
+            <a:spLocks noGrp="1"/>
+          </p:cNvSpPr>
+          <p:nvPr>
+            <p:ph type="sldImg" idx="2"/>
+          </p:nvPr>
+        </p:nvSpPr>
+        <p:spPr/>
+      </p:sp>
+      <p:sp>
+        <p:nvSpPr>
+          <p:cNvPr id="3" name="Notes Placeholder 2"/>
+          <p:cNvSpPr>
+            <a:spLocks noGrp="1"/>
+          </p:cNvSpPr>
+          <p:nvPr>
+            <p:ph type="body" idx="3" sz="quarter"/>
+          </p:nvPr>
+        </p:nvSpPr>
+        <p:spPr/>
+        <p:txBody>
+          <a:bodyPr/>
+          <a:lstStyle/>
+          <a:p>
+            <a:r>
               <a:t>Conclude by thanking Ms. Nidhi and the faculty evaluators. Invite questions and transition smoothly into the live demonstration on Render.</a:t>
             </a:r>
           </a:p>
@@ -936,7 +1006,7 @@
           <a:lstStyle/>
           <a:p>
             <a:r>
-              <a:t>Contrast standard classroom lab assignments with Club Connect. Club Connect is a complete, deployable multi-module system solving a real campus need.</a:t>
+              <a:t>Introduce Club Connect as an engineering response to scattered WhatsApp groups and manual Google forms, connecting directly to AKTU's BCC351 learning outcomes.</a:t>
             </a:r>
           </a:p>
         </p:txBody>
@@ -1006,7 +1076,7 @@
           <a:lstStyle/>
           <a:p>
             <a:r>
-              <a:t>Explain the campus problem: clubs currently use unverified Google Forms and WhatsApp. Club Connect replaces this with instant ID card verification and one official hub.</a:t>
+              <a:t>Contrast standard classroom lab assignments with Club Connect. Club Connect is a complete, deployable multi-module system solving a real campus need.</a:t>
             </a:r>
           </a:p>
         </p:txBody>
@@ -1076,7 +1146,7 @@
           <a:lstStyle/>
           <a:p>
             <a:r>
-              <a:t>Walk through the 8-stage engineering process. Highlight that we followed structured software engineering principles rather than jumping straight into coding.</a:t>
+              <a:t>Explain the campus problem: clubs currently use unverified Google Forms and WhatsApp. Club Connect replaces this with instant ID card verification and one official hub.</a:t>
             </a:r>
           </a:p>
         </p:txBody>
@@ -1146,7 +1216,7 @@
           <a:lstStyle/>
           <a:p>
             <a:r>
-              <a:t>Emphasize clear task distribution across frontend, backend, barcode integration, testing, and documentation conforming to BCC351 rubrics.</a:t>
+              <a:t>Walk through the 8-stage engineering process. Highlight that we followed structured software engineering principles rather than jumping straight into coding.</a:t>
             </a:r>
           </a:p>
         </p:txBody>
@@ -1216,7 +1286,7 @@
           <a:lstStyle/>
           <a:p>
             <a:r>
-              <a:t>Explain why Club Connect is technically and practically feasible: it requires zero expensive hardware, uses free cloud hosting, and works with our existing college ID cards.</a:t>
+              <a:t>Emphasize clear task distribution across frontend, backend, barcode integration, testing, and documentation conforming to BCC351 rubrics.</a:t>
             </a:r>
           </a:p>
         </p:txBody>
@@ -1286,7 +1356,7 @@
           <a:lstStyle/>
           <a:p>
             <a:r>
-              <a:t>Present the tech stack simply: Flutter for the web app, Python Django for the server, ZXing for barcode reading, and Render Docker for 24/7 cloud access.</a:t>
+              <a:t>Explain why Club Connect is technically and practically feasible: it requires zero expensive hardware, uses free cloud hosting, and works with our existing college ID cards.</a:t>
             </a:r>
           </a:p>
         </p:txBody>
@@ -1356,7 +1426,7 @@
           <a:lstStyle/>
           <a:p>
             <a:r>
-              <a:t>Walk through the 4-step pipeline: Student holds card $_x000D_ightarrow$ Barcode decoded $_x000D_ightarrow$ College database verifies Name and Semester $_x000D_ightarrow$ Student accesses their society dashboard.</a:t>
+              <a:t>Present the tech stack simply: Flutter for the web app, Python Django for the server, ZXing for barcode reading, and Render Docker for 24/7 cloud access.</a:t>
             </a:r>
           </a:p>
         </p:txBody>
@@ -1426,7 +1496,7 @@
           <a:lstStyle/>
           <a:p>
             <a:r>
-              <a:t>Explain why we adopted Agile Scrum instead of Waterfall. Sprints allowed us to test barcode scanning and portal sync continuously, ensuring our demo worked flawlessly.</a:t>
+              <a:t>Walk through the 4-step pipeline: Student holds card -&gt; Barcode decoded -&gt; College database verifies Name and Semester -&gt; Student accesses their society dashboard.</a:t>
             </a:r>
           </a:p>
         </p:txBody>
@@ -17221,7 +17291,7 @@
               </a:defRPr>
             </a:pPr>
             <a:r>
-              <a:t>Speaker Note: Walk through the 4-step pipeline: Student holds card $_x000D_ightarrow$ Barcode decoded $_x000D_ightarrow$ College database verifies Name and Semester $_x000D_ightarrow$ Student accesses their society dashboard.</a:t>
+              <a:t>Speaker Note: Walk through the 4-step pipeline: Student holds card -&gt; Barcode decoded -&gt; College database verifies Name and Semester -&gt; Student accesses their society dashboard.</a:t>
             </a:r>
           </a:p>
         </p:txBody>

</xml_diff>